<commit_message>
Update every remaining statement that did not match the delivered build
Report:
- add the family thanks to the acknowledgements
- match the Chapter 2 baseline values to the corrected run
- note that the loss input is a placeholder of zero
- describe the joint discrete action value and the delivered reward weights
- describe the saturating window normalisation and the window charge
- correct objectives three and five in Chapter 5
- explain Figure 3.1 step by step and remove the vehicle analogy

Slides:
- set the whole deck to Times New Roman
- update the methodology slide action and reward, and the loss placeholder note
- replace the old socket factory finding on the contribution slide with the
  real configuration ordering finding, and revise the first next step
</commit_message>
<xml_diff>
--- a/reportssofar/Okafor_Kosisochukwu_Johnpaul_FYP_Presentation_corrected.pptx
+++ b/reportssofar/Okafor_Kosisochukwu_Johnpaul_FYP_Presentation_corrected.pptx
@@ -3575,8 +3575,9 @@
             <a:pPr algn="ctr"/>
             <a:r>
               <a:rPr lang="en-GB" sz="3200" dirty="0">
-                <a:latin typeface="Corbel" panose="020B0503020204020204" pitchFamily="34" charset="0"/>
-                <a:cs typeface="Arial" panose="020B0604020202020204" pitchFamily="34" charset="0"/>
+                <a:latin typeface="Times New Roman" panose="020B0503020204020204" pitchFamily="34" charset="0"/>
+                <a:cs typeface="Times New Roman" panose="020B0604020202020204" pitchFamily="34" charset="0"/>
+                <a:ea typeface="Times New Roman"/>
               </a:rPr>
               <a:t>MULTI-AGENT REINFORCEMENT LEARNING FOR ADAPTIVE TCP CONGESTION CONTROL</a:t>
             </a:r>
@@ -3613,8 +3614,9 @@
                 <a:solidFill>
                   <a:srgbClr val="FF0000"/>
                 </a:solidFill>
-                <a:latin typeface="Corbel" panose="020B0503020204020204" pitchFamily="34" charset="0"/>
-                <a:cs typeface="Arial" panose="020B0604020202020204" pitchFamily="34" charset="0"/>
+                <a:latin typeface="Times New Roman" panose="020B0503020204020204" pitchFamily="34" charset="0"/>
+                <a:cs typeface="Times New Roman" panose="020B0604020202020204" pitchFamily="34" charset="0"/>
+                <a:ea typeface="Times New Roman"/>
               </a:rPr>
               <a:t>OKAFOR KOSISOCHUKWU JOHNPAUL</a:t>
             </a:r>
@@ -3628,8 +3630,9 @@
                 <a:solidFill>
                   <a:srgbClr val="FF0000"/>
                 </a:solidFill>
-                <a:latin typeface="Corbel" panose="020B0503020204020204" pitchFamily="34" charset="0"/>
-                <a:cs typeface="Arial" panose="020B0604020202020204" pitchFamily="34" charset="0"/>
+                <a:latin typeface="Times New Roman" panose="020B0503020204020204" pitchFamily="34" charset="0"/>
+                <a:cs typeface="Times New Roman" panose="020B0604020202020204" pitchFamily="34" charset="0"/>
+                <a:ea typeface="Times New Roman"/>
               </a:rPr>
               <a:t>REG. NO.: 20211287502</a:t>
             </a:r>
@@ -3667,8 +3670,9 @@
                 <a:solidFill>
                   <a:srgbClr val="0070C0"/>
                 </a:solidFill>
-                <a:latin typeface="Corbel" panose="020B0503020204020204" pitchFamily="34" charset="0"/>
-                <a:cs typeface="Arial" panose="020B0604020202020204" pitchFamily="34" charset="0"/>
+                <a:latin typeface="Times New Roman" panose="020B0503020204020204" pitchFamily="34" charset="0"/>
+                <a:cs typeface="Times New Roman" panose="020B0604020202020204" pitchFamily="34" charset="0"/>
+                <a:ea typeface="Times New Roman"/>
               </a:rPr>
               <a:t>SUPERVISOR: DR. IKENNA CAESAR NWANDU</a:t>
             </a:r>
@@ -3721,7 +3725,11 @@
           <a:lstStyle/>
           <a:p>
             <a:r>
-              <a:rPr lang="en-US" dirty="0"/>
+              <a:rPr lang="en-US" dirty="0">
+                <a:latin typeface="Times New Roman"/>
+                <a:ea typeface="Times New Roman"/>
+                <a:cs typeface="Times New Roman"/>
+              </a:rPr>
               <a:t>Department of Software Engineering -  project ©2025</a:t>
             </a:r>
             <a:endParaRPr lang="en-GB" dirty="0"/>
@@ -3879,8 +3887,9 @@
             <a:pPr algn="ctr"/>
             <a:r>
               <a:rPr lang="en-GB" sz="4000" dirty="0">
-                <a:latin typeface="Corbel" panose="020B0503020204020204" pitchFamily="34" charset="0"/>
-                <a:cs typeface="Arial" panose="020B0604020202020204" pitchFamily="34" charset="0"/>
+                <a:latin typeface="Times New Roman" panose="020B0503020204020204" pitchFamily="34" charset="0"/>
+                <a:cs typeface="Times New Roman" panose="020B0604020202020204" pitchFamily="34" charset="0"/>
+                <a:ea typeface="Times New Roman"/>
               </a:rPr>
               <a:t>CONTRIBUTION TO KNOWLEDGE</a:t>
             </a:r>
@@ -3945,7 +3954,11 @@
           <a:lstStyle/>
           <a:p>
             <a:r>
-              <a:rPr lang="en-US" dirty="0"/>
+              <a:rPr lang="en-US" dirty="0">
+                <a:latin typeface="Times New Roman"/>
+                <a:ea typeface="Times New Roman"/>
+                <a:cs typeface="Times New Roman"/>
+              </a:rPr>
               <a:t>Department of Software Engineering -  project  ©2025</a:t>
             </a:r>
             <a:endParaRPr lang="en-GB" dirty="0"/>
@@ -4067,7 +4080,9 @@
                 <a:solidFill>
                   <a:srgbClr val="000000"/>
                 </a:solidFill>
-                <a:latin typeface="Arial"/>
+                <a:latin typeface="Times New Roman"/>
+                <a:ea typeface="Times New Roman"/>
+                <a:cs typeface="Times New Roman"/>
               </a:rPr>
               <a:t>A reference implementation</a:t>
             </a:r>
@@ -4083,7 +4098,9 @@
                 <a:solidFill>
                   <a:srgbClr val="000000"/>
                 </a:solidFill>
-                <a:latin typeface="Arial"/>
+                <a:latin typeface="Times New Roman"/>
+                <a:ea typeface="Times New Roman"/>
+                <a:cs typeface="Times New Roman"/>
               </a:rPr>
               <a:t>A cooperative multi-agent formulation of congestion control, built with ns-3, ns3-gym, and PPO, using a reward based on Jain's Fairness Index. Code and models are public: github.com/Ksschkw/CongestiQ-FYP</a:t>
             </a:r>
@@ -4140,7 +4157,9 @@
                 <a:solidFill>
                   <a:srgbClr val="000000"/>
                 </a:solidFill>
-                <a:latin typeface="Arial"/>
+                <a:latin typeface="Times New Roman"/>
+                <a:ea typeface="Times New Roman"/>
+                <a:cs typeface="Times New Roman"/>
               </a:rPr>
               <a:t>Engineering documentation</a:t>
             </a:r>
@@ -4156,9 +4175,11 @@
                 <a:solidFill>
                   <a:srgbClr val="000000"/>
                 </a:solidFill>
-                <a:latin typeface="Arial"/>
-              </a:rPr>
-              <a:t>A record of the failure points when linking Python learning code to the ns-3 C++ transport layer: the throughput bug, the action bug, and the silent socket factory fallback.</a:t>
+                <a:latin typeface="Times New Roman"/>
+                <a:ea typeface="Times New Roman"/>
+                <a:cs typeface="Times New Roman"/>
+              </a:rPr>
+              <a:t>A record of the failure points when linking Python learning code to the ns-3 C++ transport layer: the throughput bug, the action bug, and a configuration ordering fault that silently left the default TCP algorithm in control.</a:t>
             </a:r>
           </a:p>
         </p:txBody>
@@ -4213,7 +4234,9 @@
                 <a:solidFill>
                   <a:srgbClr val="000000"/>
                 </a:solidFill>
-                <a:latin typeface="Arial"/>
+                <a:latin typeface="Times New Roman"/>
+                <a:ea typeface="Times New Roman"/>
+                <a:cs typeface="Times New Roman"/>
               </a:rPr>
               <a:t>A systems finding</a:t>
             </a:r>
@@ -4229,9 +4252,11 @@
                 <a:solidFill>
                   <a:srgbClr val="000000"/>
                 </a:solidFill>
-                <a:latin typeface="Arial"/>
-              </a:rPr>
-              <a:t>Unless a learned policy is built into the socket initialization factory, the native congestion algorithm takes back control of the window.</a:t>
+                <a:latin typeface="Times New Roman"/>
+                <a:ea typeface="Times New Roman"/>
+                <a:cs typeface="Times New Roman"/>
+              </a:rPr>
+              <a:t>A congestion control replacement must be attached after the internet stack installs on a node. The configuration API does not report a miss, so a wrong order leaves the native algorithm in control, and every metric then describes that algorithm.</a:t>
             </a:r>
           </a:p>
         </p:txBody>
@@ -4286,7 +4311,9 @@
                 <a:solidFill>
                   <a:srgbClr val="000000"/>
                 </a:solidFill>
-                <a:latin typeface="Arial"/>
+                <a:latin typeface="Times New Roman"/>
+                <a:ea typeface="Times New Roman"/>
+                <a:cs typeface="Times New Roman"/>
               </a:rPr>
               <a:t>Recommended next steps</a:t>
             </a:r>
@@ -4302,9 +4329,11 @@
                 <a:solidFill>
                   <a:srgbClr val="000000"/>
                 </a:solidFill>
-                <a:latin typeface="Arial"/>
-              </a:rPr>
-              <a:t>1. Write a custom TcpSocketBase factory.</a:t>
+                <a:latin typeface="Times New Roman"/>
+                <a:ea typeface="Times New Roman"/>
+                <a:cs typeface="Times New Roman"/>
+              </a:rPr>
+              <a:t>1. Attach the no-op congestion control after the internet stack installs, and verify it at runtime on a live socket.</a:t>
             </a:r>
           </a:p>
           <a:p>
@@ -4318,7 +4347,9 @@
                 <a:solidFill>
                   <a:srgbClr val="000000"/>
                 </a:solidFill>
-                <a:latin typeface="Arial"/>
+                <a:latin typeface="Times New Roman"/>
+                <a:ea typeface="Times New Roman"/>
+                <a:cs typeface="Times New Roman"/>
               </a:rPr>
               <a:t>2. Compile the trained network into an Extended Berkeley Packet Filter (eBPF) program for the Linux kernel.</a:t>
             </a:r>
@@ -4334,7 +4365,9 @@
                 <a:solidFill>
                   <a:srgbClr val="000000"/>
                 </a:solidFill>
-                <a:latin typeface="Arial"/>
+                <a:latin typeface="Times New Roman"/>
+                <a:ea typeface="Times New Roman"/>
+                <a:cs typeface="Times New Roman"/>
               </a:rPr>
               <a:t>3. Test in an emulator such as Mininet.</a:t>
             </a:r>
@@ -4350,7 +4383,9 @@
                 <a:solidFill>
                   <a:srgbClr val="000000"/>
                 </a:solidFill>
-                <a:latin typeface="Arial"/>
+                <a:latin typeface="Times New Roman"/>
+                <a:ea typeface="Times New Roman"/>
+                <a:cs typeface="Times New Roman"/>
               </a:rPr>
               <a:t>4. Trigger decisions once per round-trip time, not on a 100 ms timer.</a:t>
             </a:r>
@@ -4428,9 +4463,9 @@
           <a:p>
             <a:r>
               <a:rPr lang="de-DE" sz="6600" b="1" dirty="0">
-                <a:latin typeface="Corbel" panose="020B0503020204020204" pitchFamily="34" charset="0"/>
-                <a:ea typeface="Arial" charset="0"/>
-                <a:cs typeface="Arial" charset="0"/>
+                <a:latin typeface="Times New Roman" panose="020B0503020204020204" pitchFamily="34" charset="0"/>
+                <a:ea typeface="Times New Roman" charset="0"/>
+                <a:cs typeface="Times New Roman" charset="0"/>
               </a:rPr>
               <a:t>QUESTIONS?</a:t>
             </a:r>
@@ -4483,7 +4518,11 @@
           <a:lstStyle/>
           <a:p>
             <a:r>
-              <a:rPr lang="en-US" dirty="0"/>
+              <a:rPr lang="en-US" dirty="0">
+                <a:latin typeface="Times New Roman"/>
+                <a:ea typeface="Times New Roman"/>
+                <a:cs typeface="Times New Roman"/>
+              </a:rPr>
               <a:t>Department of Software Engineering -  Project  ©2025</a:t>
             </a:r>
             <a:endParaRPr lang="en-GB" dirty="0"/>
@@ -4627,9 +4666,9 @@
             <a:pPr algn="ctr"/>
             <a:r>
               <a:rPr lang="de-DE" sz="6600" b="1" dirty="0">
-                <a:latin typeface="Corbel" panose="020B0503020204020204" pitchFamily="34" charset="0"/>
-                <a:ea typeface="Arial" charset="0"/>
-                <a:cs typeface="Arial" charset="0"/>
+                <a:latin typeface="Times New Roman" panose="020B0503020204020204" pitchFamily="34" charset="0"/>
+                <a:ea typeface="Times New Roman" charset="0"/>
+                <a:cs typeface="Times New Roman" charset="0"/>
               </a:rPr>
               <a:t>Thank you for listening </a:t>
             </a:r>
@@ -4682,7 +4721,11 @@
           <a:lstStyle/>
           <a:p>
             <a:r>
-              <a:rPr lang="en-US" dirty="0"/>
+              <a:rPr lang="en-US" dirty="0">
+                <a:latin typeface="Times New Roman"/>
+                <a:ea typeface="Times New Roman"/>
+                <a:cs typeface="Times New Roman"/>
+              </a:rPr>
               <a:t>Department of Software Engineering -  Project ©2025</a:t>
             </a:r>
             <a:endParaRPr lang="en-GB" dirty="0"/>
@@ -4828,8 +4871,9 @@
             <a:pPr algn="ctr"/>
             <a:r>
               <a:rPr lang="en-GB" sz="4000" dirty="0">
-                <a:latin typeface="Arial" panose="020B0604020202020204" pitchFamily="34" charset="0"/>
-                <a:cs typeface="Arial" panose="020B0604020202020204" pitchFamily="34" charset="0"/>
+                <a:latin typeface="Times New Roman" panose="020B0604020202020204" pitchFamily="34" charset="0"/>
+                <a:cs typeface="Times New Roman" panose="020B0604020202020204" pitchFamily="34" charset="0"/>
+                <a:ea typeface="Times New Roman"/>
               </a:rPr>
               <a:t>INTRODUCTION</a:t>
             </a:r>
@@ -4882,7 +4926,11 @@
           <a:lstStyle/>
           <a:p>
             <a:r>
-              <a:rPr lang="en-US" dirty="0"/>
+              <a:rPr lang="en-US" dirty="0">
+                <a:latin typeface="Times New Roman"/>
+                <a:ea typeface="Times New Roman"/>
+                <a:cs typeface="Times New Roman"/>
+              </a:rPr>
               <a:t>Department of Software Engineering -  Project  ©2025</a:t>
             </a:r>
             <a:endParaRPr lang="en-GB" dirty="0"/>
@@ -4987,7 +5035,9 @@
                 <a:solidFill>
                   <a:srgbClr val="000000"/>
                 </a:solidFill>
-                <a:latin typeface="Arial"/>
+                <a:latin typeface="Times New Roman"/>
+                <a:ea typeface="Times New Roman"/>
+                <a:cs typeface="Times New Roman"/>
               </a:rPr>
               <a:t>Data on the internet travels as small units called packets. </a:t>
             </a:r>
@@ -4996,7 +5046,9 @@
                 <a:solidFill>
                   <a:srgbClr val="000000"/>
                 </a:solidFill>
-                <a:latin typeface="Arial"/>
+                <a:latin typeface="Times New Roman"/>
+                <a:ea typeface="Times New Roman"/>
+                <a:cs typeface="Times New Roman"/>
               </a:rPr>
               <a:t>Transmission Control Protocol (TCP)</a:t>
             </a:r>
@@ -5005,7 +5057,9 @@
                 <a:solidFill>
                   <a:srgbClr val="000000"/>
                 </a:solidFill>
-                <a:latin typeface="Arial"/>
+                <a:latin typeface="Times New Roman"/>
+                <a:ea typeface="Times New Roman"/>
+                <a:cs typeface="Times New Roman"/>
               </a:rPr>
               <a:t> makes sure they arrive reliably.</a:t>
             </a:r>
@@ -5022,7 +5076,9 @@
                 <a:solidFill>
                   <a:srgbClr val="000000"/>
                 </a:solidFill>
-                <a:latin typeface="Arial"/>
+                <a:latin typeface="Times New Roman"/>
+                <a:ea typeface="Times New Roman"/>
+                <a:cs typeface="Times New Roman"/>
               </a:rPr>
               <a:t>A sender cannot see how full a router's memory buffer is. It infers congestion from packet loss and delay, and limits the data in transit with a value called the congestion window (CWND).</a:t>
             </a:r>
@@ -5039,7 +5095,9 @@
                 <a:solidFill>
                   <a:srgbClr val="000000"/>
                 </a:solidFill>
-                <a:latin typeface="Arial"/>
+                <a:latin typeface="Times New Roman"/>
+                <a:ea typeface="Times New Roman"/>
+                <a:cs typeface="Times New Roman"/>
               </a:rPr>
               <a:t>TCP Reno and TCP CUBIC follow fixed rules and treat packet loss as congestion. Bottleneck Bandwidth and Round-trip propagation time (BBR) instead builds a model of the network path.</a:t>
             </a:r>
@@ -5056,7 +5114,9 @@
                 <a:solidFill>
                   <a:srgbClr val="000000"/>
                 </a:solidFill>
-                <a:latin typeface="Arial"/>
+                <a:latin typeface="Times New Roman"/>
+                <a:ea typeface="Times New Roman"/>
+                <a:cs typeface="Times New Roman"/>
               </a:rPr>
               <a:t>Reinforcement Learning (RL)</a:t>
             </a:r>
@@ -5065,7 +5125,9 @@
                 <a:solidFill>
                   <a:srgbClr val="000000"/>
                 </a:solidFill>
-                <a:latin typeface="Arial"/>
+                <a:latin typeface="Times New Roman"/>
+                <a:ea typeface="Times New Roman"/>
+                <a:cs typeface="Times New Roman"/>
               </a:rPr>
               <a:t> lets a sender learn its own control policy from observations and reward feedback.</a:t>
             </a:r>
@@ -5082,7 +5144,9 @@
                 <a:solidFill>
                   <a:srgbClr val="000000"/>
                 </a:solidFill>
-                <a:latin typeface="Arial"/>
+                <a:latin typeface="Times New Roman"/>
+                <a:ea typeface="Times New Roman"/>
+                <a:cs typeface="Times New Roman"/>
               </a:rPr>
               <a:t>This project uses </a:t>
             </a:r>
@@ -5091,7 +5155,9 @@
                 <a:solidFill>
                   <a:srgbClr val="000000"/>
                 </a:solidFill>
-                <a:latin typeface="Arial"/>
+                <a:latin typeface="Times New Roman"/>
+                <a:ea typeface="Times New Roman"/>
+                <a:cs typeface="Times New Roman"/>
               </a:rPr>
               <a:t>Multi-Agent RL (MARL)</a:t>
             </a:r>
@@ -5100,7 +5166,9 @@
                 <a:solidFill>
                   <a:srgbClr val="000000"/>
                 </a:solidFill>
-                <a:latin typeface="Arial"/>
+                <a:latin typeface="Times New Roman"/>
+                <a:ea typeface="Times New Roman"/>
+                <a:cs typeface="Times New Roman"/>
               </a:rPr>
               <a:t>, where several senders learn together on one shared link.</a:t>
             </a:r>
@@ -5163,7 +5231,9 @@
                 <a:solidFill>
                   <a:srgbClr val="404040"/>
                 </a:solidFill>
-                <a:latin typeface="Arial"/>
+                <a:latin typeface="Times New Roman"/>
+                <a:ea typeface="Times New Roman"/>
+                <a:cs typeface="Times New Roman"/>
               </a:rPr>
               <a:t>Figure 1.1: The RL control cycle for congestion control.</a:t>
             </a:r>
@@ -5244,8 +5314,9 @@
             <a:pPr algn="ctr"/>
             <a:r>
               <a:rPr lang="en-GB" sz="4000" dirty="0">
-                <a:latin typeface="Corbel" panose="020B0503020204020204" pitchFamily="34" charset="0"/>
-                <a:cs typeface="Arial" panose="020B0604020202020204" pitchFamily="34" charset="0"/>
+                <a:latin typeface="Times New Roman" panose="020B0503020204020204" pitchFamily="34" charset="0"/>
+                <a:cs typeface="Times New Roman" panose="020B0604020202020204" pitchFamily="34" charset="0"/>
+                <a:ea typeface="Times New Roman"/>
               </a:rPr>
               <a:t>PROBLEM STATEMENT</a:t>
             </a:r>
@@ -5298,7 +5369,11 @@
           <a:lstStyle/>
           <a:p>
             <a:r>
-              <a:rPr lang="en-US" dirty="0"/>
+              <a:rPr lang="en-US" dirty="0">
+                <a:latin typeface="Times New Roman"/>
+                <a:ea typeface="Times New Roman"/>
+                <a:cs typeface="Times New Roman"/>
+              </a:rPr>
               <a:t>Department of Software Engineering -  Project  ©2025</a:t>
             </a:r>
             <a:endParaRPr lang="en-GB" dirty="0"/>
@@ -5420,7 +5495,9 @@
                 <a:solidFill>
                   <a:srgbClr val="000000"/>
                 </a:solidFill>
-                <a:latin typeface="Arial"/>
+                <a:latin typeface="Times New Roman"/>
+                <a:ea typeface="Times New Roman"/>
+                <a:cs typeface="Times New Roman"/>
               </a:rPr>
               <a:t>Loss-based algorithms (Reno, CUBIC)</a:t>
             </a:r>
@@ -5436,7 +5513,9 @@
                 <a:solidFill>
                   <a:srgbClr val="000000"/>
                 </a:solidFill>
-                <a:latin typeface="Arial"/>
+                <a:latin typeface="Times New Roman"/>
+                <a:ea typeface="Times New Roman"/>
+                <a:cs typeface="Times New Roman"/>
               </a:rPr>
               <a:t>They assume every packet drop means a router queue overflowed. On wireless links, signal interference also drops packets, so these algorithms cut the CWND when they should not. The link is then underused.</a:t>
             </a:r>
@@ -5493,7 +5572,9 @@
                 <a:solidFill>
                   <a:srgbClr val="000000"/>
                 </a:solidFill>
-                <a:latin typeface="Arial"/>
+                <a:latin typeface="Times New Roman"/>
+                <a:ea typeface="Times New Roman"/>
+                <a:cs typeface="Times New Roman"/>
               </a:rPr>
               <a:t>Model-based algorithm (BBR)</a:t>
             </a:r>
@@ -5509,7 +5590,9 @@
                 <a:solidFill>
                   <a:srgbClr val="000000"/>
                 </a:solidFill>
-                <a:latin typeface="Arial"/>
+                <a:latin typeface="Times New Roman"/>
+                <a:ea typeface="Times New Roman"/>
+                <a:cs typeface="Times New Roman"/>
               </a:rPr>
               <a:t>BBR does not cut its rate when loss occurs. On a link shared with loss-based flows, it can starve them and split bandwidth unequally.</a:t>
             </a:r>
@@ -5566,7 +5649,9 @@
                 <a:solidFill>
                   <a:srgbClr val="000000"/>
                 </a:solidFill>
-                <a:latin typeface="Arial"/>
+                <a:latin typeface="Times New Roman"/>
+                <a:ea typeface="Times New Roman"/>
+                <a:cs typeface="Times New Roman"/>
               </a:rPr>
               <a:t>Single-agent RL</a:t>
             </a:r>
@@ -5582,7 +5667,9 @@
                 <a:solidFill>
                   <a:srgbClr val="000000"/>
                 </a:solidFill>
-                <a:latin typeface="Arial"/>
+                <a:latin typeface="Times New Roman"/>
+                <a:ea typeface="Times New Roman"/>
+                <a:cs typeface="Times New Roman"/>
               </a:rPr>
               <a:t>Most existing RL work uses one agent, which treats other flows as random noise. In competition it can take a disproportionate share of buffer space and starve other flows.</a:t>
             </a:r>
@@ -5639,7 +5726,9 @@
                 <a:solidFill>
                   <a:srgbClr val="000000"/>
                 </a:solidFill>
-                <a:latin typeface="Arial"/>
+                <a:latin typeface="Times New Roman"/>
+                <a:ea typeface="Times New Roman"/>
+                <a:cs typeface="Times New Roman"/>
               </a:rPr>
               <a:t>Standards requirement</a:t>
             </a:r>
@@ -5655,7 +5744,9 @@
                 <a:solidFill>
                   <a:srgbClr val="000000"/>
                 </a:solidFill>
-                <a:latin typeface="Arial"/>
+                <a:latin typeface="Times New Roman"/>
+                <a:ea typeface="Times New Roman"/>
+                <a:cs typeface="Times New Roman"/>
               </a:rPr>
               <a:t>The Internet Engineering Task Force (IETF) requires in RFC 9743 that a new algorithm coexists safely and shares capacity fairly. Single-agent RL does not address this, which motivates a multi-agent approach.</a:t>
             </a:r>
@@ -5736,8 +5827,9 @@
             <a:pPr algn="ctr"/>
             <a:r>
               <a:rPr lang="en-GB" sz="4000" dirty="0">
-                <a:latin typeface="Corbel" panose="020B0503020204020204" pitchFamily="34" charset="0"/>
-                <a:cs typeface="Arial" panose="020B0604020202020204" pitchFamily="34" charset="0"/>
+                <a:latin typeface="Times New Roman" panose="020B0503020204020204" pitchFamily="34" charset="0"/>
+                <a:cs typeface="Times New Roman" panose="020B0604020202020204" pitchFamily="34" charset="0"/>
+                <a:ea typeface="Times New Roman"/>
               </a:rPr>
               <a:t>MAIN OBJECTIVES </a:t>
             </a:r>
@@ -5790,7 +5882,11 @@
           <a:lstStyle/>
           <a:p>
             <a:r>
-              <a:rPr lang="en-US" dirty="0"/>
+              <a:rPr lang="en-US" dirty="0">
+                <a:latin typeface="Times New Roman"/>
+                <a:ea typeface="Times New Roman"/>
+                <a:cs typeface="Times New Roman"/>
+              </a:rPr>
               <a:t>Department of Software Engineering -  Project ©2025</a:t>
             </a:r>
             <a:endParaRPr lang="en-GB" dirty="0"/>
@@ -5912,7 +6008,9 @@
                 <a:solidFill>
                   <a:srgbClr val="000000"/>
                 </a:solidFill>
-                <a:latin typeface="Arial"/>
+                <a:latin typeface="Times New Roman"/>
+                <a:ea typeface="Times New Roman"/>
+                <a:cs typeface="Times New Roman"/>
               </a:rPr>
               <a:t>Main objective</a:t>
             </a:r>
@@ -5928,7 +6026,9 @@
                 <a:solidFill>
                   <a:srgbClr val="000000"/>
                 </a:solidFill>
-                <a:latin typeface="Arial"/>
+                <a:latin typeface="Times New Roman"/>
+                <a:ea typeface="Times New Roman"/>
+                <a:cs typeface="Times New Roman"/>
               </a:rPr>
               <a:t>To design, implement, and evaluate a Multi-Agent Reinforcement Learning (MARL) framework for Transmission Control Protocol (TCP) congestion control that optimizes bandwidth utilization and reduces queueing delay, while keeping bandwidth fair among competing flows and staying within realistic computational limits.</a:t>
             </a:r>
@@ -5985,7 +6085,9 @@
                 <a:solidFill>
                   <a:srgbClr val="000000"/>
                 </a:solidFill>
-                <a:latin typeface="Arial"/>
+                <a:latin typeface="Times New Roman"/>
+                <a:ea typeface="Times New Roman"/>
+                <a:cs typeface="Times New Roman"/>
               </a:rPr>
               <a:t>Scope</a:t>
             </a:r>
@@ -6001,7 +6103,9 @@
                 <a:solidFill>
                   <a:srgbClr val="000000"/>
                 </a:solidFill>
-                <a:latin typeface="Arial"/>
+                <a:latin typeface="Times New Roman"/>
+                <a:ea typeface="Times New Roman"/>
+                <a:cs typeface="Times New Roman"/>
               </a:rPr>
               <a:t>Simulation only, using Network Simulator 3 (ns-3). Training is done offline.</a:t>
             </a:r>
@@ -6058,7 +6162,9 @@
                 <a:solidFill>
                   <a:srgbClr val="000000"/>
                 </a:solidFill>
-                <a:latin typeface="Arial"/>
+                <a:latin typeface="Times New Roman"/>
+                <a:ea typeface="Times New Roman"/>
+                <a:cs typeface="Times New Roman"/>
               </a:rPr>
               <a:t>Network setup</a:t>
             </a:r>
@@ -6074,7 +6180,9 @@
                 <a:solidFill>
                   <a:srgbClr val="000000"/>
                 </a:solidFill>
-                <a:latin typeface="Arial"/>
+                <a:latin typeface="Times New Roman"/>
+                <a:ea typeface="Times New Roman"/>
+                <a:cs typeface="Times New Roman"/>
               </a:rPr>
               <a:t>Dumbbell topology with a 10 Mbps bottleneck link and 20 ms one-way delay.</a:t>
             </a:r>
@@ -6131,7 +6239,9 @@
                 <a:solidFill>
                   <a:srgbClr val="000000"/>
                 </a:solidFill>
-                <a:latin typeface="Arial"/>
+                <a:latin typeface="Times New Roman"/>
+                <a:ea typeface="Times New Roman"/>
+                <a:cs typeface="Times New Roman"/>
               </a:rPr>
               <a:t>Out of scope</a:t>
             </a:r>
@@ -6147,7 +6257,9 @@
                 <a:solidFill>
                   <a:srgbClr val="000000"/>
                 </a:solidFill>
-                <a:latin typeface="Arial"/>
+                <a:latin typeface="Times New Roman"/>
+                <a:ea typeface="Times New Roman"/>
+                <a:cs typeface="Times New Roman"/>
               </a:rPr>
               <a:t>Changes to the live Linux kernel and tests on real hardware or live internet links.</a:t>
             </a:r>
@@ -6240,8 +6352,9 @@
             <a:pPr algn="ctr"/>
             <a:r>
               <a:rPr lang="en-GB" sz="4000" dirty="0">
-                <a:latin typeface="Corbel" panose="020B0503020204020204" pitchFamily="34" charset="0"/>
-                <a:cs typeface="Arial" panose="020B0604020202020204" pitchFamily="34" charset="0"/>
+                <a:latin typeface="Times New Roman" panose="020B0503020204020204" pitchFamily="34" charset="0"/>
+                <a:cs typeface="Times New Roman" panose="020B0604020202020204" pitchFamily="34" charset="0"/>
+                <a:ea typeface="Times New Roman"/>
               </a:rPr>
               <a:t>SPECIFIC OBJECTIVES </a:t>
             </a:r>
@@ -6306,7 +6419,11 @@
           <a:lstStyle/>
           <a:p>
             <a:r>
-              <a:rPr lang="en-US" dirty="0"/>
+              <a:rPr lang="en-US" dirty="0">
+                <a:latin typeface="Times New Roman"/>
+                <a:ea typeface="Times New Roman"/>
+                <a:cs typeface="Times New Roman"/>
+              </a:rPr>
               <a:t>Department of Software Engineering -  Project ©2025</a:t>
             </a:r>
             <a:endParaRPr lang="en-GB" dirty="0"/>
@@ -6428,7 +6545,9 @@
                 <a:solidFill>
                   <a:srgbClr val="000000"/>
                 </a:solidFill>
-                <a:latin typeface="Arial"/>
+                <a:latin typeface="Times New Roman"/>
+                <a:ea typeface="Times New Roman"/>
+                <a:cs typeface="Times New Roman"/>
               </a:rPr>
               <a:t>1. Examine loss-based TCP</a:t>
             </a:r>
@@ -6444,7 +6563,9 @@
                 <a:solidFill>
                   <a:srgbClr val="000000"/>
                 </a:solidFill>
-                <a:latin typeface="Arial"/>
+                <a:latin typeface="Times New Roman"/>
+                <a:ea typeface="Times New Roman"/>
+                <a:cs typeface="Times New Roman"/>
               </a:rPr>
               <a:t>Study TCP Reno and TCP CUBIC: how they work, their throughput limits, and bufferbloat (high delay from over-full router buffers).</a:t>
             </a:r>
@@ -6501,7 +6622,9 @@
                 <a:solidFill>
                   <a:srgbClr val="000000"/>
                 </a:solidFill>
-                <a:latin typeface="Arial"/>
+                <a:latin typeface="Times New Roman"/>
+                <a:ea typeface="Times New Roman"/>
+                <a:cs typeface="Times New Roman"/>
               </a:rPr>
               <a:t>2. Analyze BBR</a:t>
             </a:r>
@@ -6517,7 +6640,9 @@
                 <a:solidFill>
                   <a:srgbClr val="000000"/>
                 </a:solidFill>
-                <a:latin typeface="Arial"/>
+                <a:latin typeface="Times New Roman"/>
+                <a:ea typeface="Times New Roman"/>
+                <a:cs typeface="Times New Roman"/>
               </a:rPr>
               <a:t>Identify BBR fairness problems and throughput loss when it competes with loss-based flows.</a:t>
             </a:r>
@@ -6574,7 +6699,9 @@
                 <a:solidFill>
                   <a:srgbClr val="000000"/>
                 </a:solidFill>
-                <a:latin typeface="Arial"/>
+                <a:latin typeface="Times New Roman"/>
+                <a:ea typeface="Times New Roman"/>
+                <a:cs typeface="Times New Roman"/>
               </a:rPr>
               <a:t>3. Formulate the problem</a:t>
             </a:r>
@@ -6590,7 +6717,9 @@
                 <a:solidFill>
                   <a:srgbClr val="000000"/>
                 </a:solidFill>
-                <a:latin typeface="Arial"/>
+                <a:latin typeface="Times New Roman"/>
+                <a:ea typeface="Times New Roman"/>
+                <a:cs typeface="Times New Roman"/>
               </a:rPr>
               <a:t>Express congestion control as a Markov Decision Process (MDP) with states, actions, and a cooperative reward.</a:t>
             </a:r>
@@ -6647,7 +6776,9 @@
                 <a:solidFill>
                   <a:srgbClr val="000000"/>
                 </a:solidFill>
-                <a:latin typeface="Arial"/>
+                <a:latin typeface="Times New Roman"/>
+                <a:ea typeface="Times New Roman"/>
+                <a:cs typeface="Times New Roman"/>
               </a:rPr>
               <a:t>4. Build a testbed</a:t>
             </a:r>
@@ -6663,7 +6794,9 @@
                 <a:solidFill>
                   <a:srgbClr val="000000"/>
                 </a:solidFill>
-                <a:latin typeface="Arial"/>
+                <a:latin typeface="Times New Roman"/>
+                <a:ea typeface="Times New Roman"/>
+                <a:cs typeface="Times New Roman"/>
               </a:rPr>
               <a:t>Connect Network Simulator 3 (ns-3) to Python through the ns3-gym bridge and the OpenAI Gymnasium interface.</a:t>
             </a:r>
@@ -6720,7 +6853,9 @@
                 <a:solidFill>
                   <a:srgbClr val="000000"/>
                 </a:solidFill>
-                <a:latin typeface="Arial"/>
+                <a:latin typeface="Times New Roman"/>
+                <a:ea typeface="Times New Roman"/>
+                <a:cs typeface="Times New Roman"/>
               </a:rPr>
               <a:t>5. Train a shared policy</a:t>
             </a:r>
@@ -6736,7 +6871,9 @@
                 <a:solidFill>
                   <a:srgbClr val="000000"/>
                 </a:solidFill>
-                <a:latin typeface="Arial"/>
+                <a:latin typeface="Times New Roman"/>
+                <a:ea typeface="Times New Roman"/>
+                <a:cs typeface="Times New Roman"/>
               </a:rPr>
               <a:t>Use Proximal Policy Optimization (PPO) under Centralised Training with Decentralised Execution (CTDE).</a:t>
             </a:r>
@@ -6793,7 +6930,9 @@
                 <a:solidFill>
                   <a:srgbClr val="000000"/>
                 </a:solidFill>
-                <a:latin typeface="Arial"/>
+                <a:latin typeface="Times New Roman"/>
+                <a:ea typeface="Times New Roman"/>
+                <a:cs typeface="Times New Roman"/>
               </a:rPr>
               <a:t>6. Evaluate</a:t>
             </a:r>
@@ -6809,7 +6948,9 @@
                 <a:solidFill>
                   <a:srgbClr val="000000"/>
                 </a:solidFill>
-                <a:latin typeface="Arial"/>
+                <a:latin typeface="Times New Roman"/>
+                <a:ea typeface="Times New Roman"/>
+                <a:cs typeface="Times New Roman"/>
               </a:rPr>
               <a:t>Compare the agent with Reno, CUBIC, and BBR on throughput, delay, loss ratio, and Jain's Fairness Index (RFC 9743 metrics).</a:t>
             </a:r>
@@ -6890,8 +7031,9 @@
             <a:pPr algn="ctr"/>
             <a:r>
               <a:rPr lang="en-GB" sz="4000" dirty="0">
-                <a:latin typeface="Corbel" panose="020B0503020204020204" pitchFamily="34" charset="0"/>
-                <a:cs typeface="Arial" panose="020B0604020202020204" pitchFamily="34" charset="0"/>
+                <a:latin typeface="Times New Roman" panose="020B0503020204020204" pitchFamily="34" charset="0"/>
+                <a:cs typeface="Times New Roman" panose="020B0604020202020204" pitchFamily="34" charset="0"/>
+                <a:ea typeface="Times New Roman"/>
               </a:rPr>
               <a:t>METHODOLOGY </a:t>
             </a:r>
@@ -6944,7 +7086,11 @@
           <a:lstStyle/>
           <a:p>
             <a:r>
-              <a:rPr lang="en-US" dirty="0"/>
+              <a:rPr lang="en-US" dirty="0">
+                <a:latin typeface="Times New Roman"/>
+                <a:ea typeface="Times New Roman"/>
+                <a:cs typeface="Times New Roman"/>
+              </a:rPr>
               <a:t>Department of Software Engineering -  project©2025</a:t>
             </a:r>
             <a:endParaRPr lang="en-GB" dirty="0"/>
@@ -7049,7 +7195,9 @@
                 <a:solidFill>
                   <a:srgbClr val="000000"/>
                 </a:solidFill>
-                <a:latin typeface="Arial"/>
+                <a:latin typeface="Times New Roman"/>
+                <a:ea typeface="Times New Roman"/>
+                <a:cs typeface="Times New Roman"/>
               </a:rPr>
               <a:t>Simulation-based, offline training. </a:t>
             </a:r>
@@ -7058,7 +7206,9 @@
                 <a:solidFill>
                   <a:srgbClr val="000000"/>
                 </a:solidFill>
-                <a:latin typeface="Arial"/>
+                <a:latin typeface="Times New Roman"/>
+                <a:ea typeface="Times New Roman"/>
+                <a:cs typeface="Times New Roman"/>
               </a:rPr>
               <a:t>All work runs inside Network Simulator 3 (ns-3), a discrete-event simulator, so a learning agent can explore without risking a real network.</a:t>
             </a:r>
@@ -7075,7 +7225,9 @@
                 <a:solidFill>
                   <a:srgbClr val="000000"/>
                 </a:solidFill>
-                <a:latin typeface="Arial"/>
+                <a:latin typeface="Times New Roman"/>
+                <a:ea typeface="Times New Roman"/>
+                <a:cs typeface="Times New Roman"/>
               </a:rPr>
               <a:t>Centralised Training with Decentralised Execution (CTDE). </a:t>
             </a:r>
@@ -7084,7 +7236,9 @@
                 <a:solidFill>
                   <a:srgbClr val="000000"/>
                 </a:solidFill>
-                <a:latin typeface="Arial"/>
+                <a:latin typeface="Times New Roman"/>
+                <a:ea typeface="Times New Roman"/>
+                <a:cs typeface="Times New Roman"/>
               </a:rPr>
               <a:t>During training, one process sees all flows and trains a single shared policy. After training the weights are frozen, and each sender applies the policy using only its own observations.</a:t>
             </a:r>
@@ -7123,7 +7277,9 @@
                 <a:solidFill>
                   <a:srgbClr val="000000"/>
                 </a:solidFill>
-                <a:latin typeface="Arial"/>
+                <a:latin typeface="Times New Roman"/>
+                <a:ea typeface="Times New Roman"/>
+                <a:cs typeface="Times New Roman"/>
               </a:rPr>
               <a:t>The problem is framed as a Markov Decision Process (MDP): what the agent sees, what it does, and how it is scored.</a:t>
             </a:r>
@@ -7180,7 +7336,9 @@
                 <a:solidFill>
                   <a:srgbClr val="000000"/>
                 </a:solidFill>
-                <a:latin typeface="Arial"/>
+                <a:latin typeface="Times New Roman"/>
+                <a:ea typeface="Times New Roman"/>
+                <a:cs typeface="Times New Roman"/>
               </a:rPr>
               <a:t>State (what it sees)</a:t>
             </a:r>
@@ -7196,7 +7354,9 @@
                 <a:solidFill>
                   <a:srgbClr val="000000"/>
                 </a:solidFill>
-                <a:latin typeface="Arial"/>
+                <a:latin typeface="Times New Roman"/>
+                <a:ea typeface="Times New Roman"/>
+                <a:cs typeface="Times New Roman"/>
               </a:rPr>
               <a:t>Four values per flow:</a:t>
             </a:r>
@@ -7212,7 +7372,9 @@
                 <a:solidFill>
                   <a:srgbClr val="000000"/>
                 </a:solidFill>
-                <a:latin typeface="Arial"/>
+                <a:latin typeface="Times New Roman"/>
+                <a:ea typeface="Times New Roman"/>
+                <a:cs typeface="Times New Roman"/>
               </a:rPr>
               <a:t>1. Congestion window</a:t>
             </a:r>
@@ -7228,7 +7390,9 @@
                 <a:solidFill>
                   <a:srgbClr val="000000"/>
                 </a:solidFill>
-                <a:latin typeface="Arial"/>
+                <a:latin typeface="Times New Roman"/>
+                <a:ea typeface="Times New Roman"/>
+                <a:cs typeface="Times New Roman"/>
               </a:rPr>
               <a:t>2. Smoothed round-trip time</a:t>
             </a:r>
@@ -7244,7 +7408,9 @@
                 <a:solidFill>
                   <a:srgbClr val="000000"/>
                 </a:solidFill>
-                <a:latin typeface="Arial"/>
+                <a:latin typeface="Times New Roman"/>
+                <a:ea typeface="Times New Roman"/>
+                <a:cs typeface="Times New Roman"/>
               </a:rPr>
               <a:t>3. Packet loss count</a:t>
             </a:r>
@@ -7260,7 +7426,9 @@
                 <a:solidFill>
                   <a:srgbClr val="000000"/>
                 </a:solidFill>
-                <a:latin typeface="Arial"/>
+                <a:latin typeface="Times New Roman"/>
+                <a:ea typeface="Times New Roman"/>
+                <a:cs typeface="Times New Roman"/>
               </a:rPr>
               <a:t>4. Throughput delivery rate</a:t>
             </a:r>
@@ -7276,9 +7444,11 @@
                 <a:solidFill>
                   <a:srgbClr val="000000"/>
                 </a:solidFill>
-                <a:latin typeface="Arial"/>
-              </a:rPr>
-              <a:t>Two flows give a vector of eight numbers, scaled to bounded ranges before reaching the neural network.</a:t>
+                <a:latin typeface="Times New Roman"/>
+                <a:ea typeface="Times New Roman"/>
+                <a:cs typeface="Times New Roman"/>
+              </a:rPr>
+              <a:t>Two flows give a vector of eight numbers, scaled to bounded ranges before reaching the neural network. The loss input is a placeholder; packet loss is measured after each run from FlowMonitor.</a:t>
             </a:r>
           </a:p>
         </p:txBody>
@@ -7333,7 +7503,9 @@
                 <a:solidFill>
                   <a:srgbClr val="000000"/>
                 </a:solidFill>
-                <a:latin typeface="Arial"/>
+                <a:latin typeface="Times New Roman"/>
+                <a:ea typeface="Times New Roman"/>
+                <a:cs typeface="Times New Roman"/>
               </a:rPr>
               <a:t>Action (what it does)</a:t>
             </a:r>
@@ -7349,9 +7521,11 @@
                 <a:solidFill>
                   <a:srgbClr val="000000"/>
                 </a:solidFill>
-                <a:latin typeface="Arial"/>
-              </a:rPr>
-              <a:t>One integer from 0 to 4 per flow, changing the window:</a:t>
+                <a:latin typeface="Times New Roman"/>
+                <a:ea typeface="Times New Roman"/>
+                <a:cs typeface="Times New Roman"/>
+              </a:rPr>
+              <a:t>Each agent chooses one integer from 0 to 4, and the pair is sent as one joint value from 0 to 24, changing the window:</a:t>
             </a:r>
           </a:p>
           <a:p>
@@ -7365,7 +7539,9 @@
                 <a:solidFill>
                   <a:srgbClr val="000000"/>
                 </a:solidFill>
-                <a:latin typeface="Arial"/>
+                <a:latin typeface="Times New Roman"/>
+                <a:ea typeface="Times New Roman"/>
+                <a:cs typeface="Times New Roman"/>
               </a:rPr>
               <a:t>0: keep the window</a:t>
             </a:r>
@@ -7381,7 +7557,9 @@
                 <a:solidFill>
                   <a:srgbClr val="000000"/>
                 </a:solidFill>
-                <a:latin typeface="Arial"/>
+                <a:latin typeface="Times New Roman"/>
+                <a:ea typeface="Times New Roman"/>
+                <a:cs typeface="Times New Roman"/>
               </a:rPr>
               <a:t>1: increase by 10%</a:t>
             </a:r>
@@ -7397,7 +7575,9 @@
                 <a:solidFill>
                   <a:srgbClr val="000000"/>
                 </a:solidFill>
-                <a:latin typeface="Arial"/>
+                <a:latin typeface="Times New Roman"/>
+                <a:ea typeface="Times New Roman"/>
+                <a:cs typeface="Times New Roman"/>
               </a:rPr>
               <a:t>2: decrease by 10%</a:t>
             </a:r>
@@ -7413,7 +7593,9 @@
                 <a:solidFill>
                   <a:srgbClr val="000000"/>
                 </a:solidFill>
-                <a:latin typeface="Arial"/>
+                <a:latin typeface="Times New Roman"/>
+                <a:ea typeface="Times New Roman"/>
+                <a:cs typeface="Times New Roman"/>
               </a:rPr>
               <a:t>3: increase by 20%</a:t>
             </a:r>
@@ -7429,7 +7611,9 @@
                 <a:solidFill>
                   <a:srgbClr val="000000"/>
                 </a:solidFill>
-                <a:latin typeface="Arial"/>
+                <a:latin typeface="Times New Roman"/>
+                <a:ea typeface="Times New Roman"/>
+                <a:cs typeface="Times New Roman"/>
               </a:rPr>
               <a:t>4: decrease by 20%</a:t>
             </a:r>
@@ -7486,7 +7670,9 @@
                 <a:solidFill>
                   <a:srgbClr val="000000"/>
                 </a:solidFill>
-                <a:latin typeface="Arial"/>
+                <a:latin typeface="Times New Roman"/>
+                <a:ea typeface="Times New Roman"/>
+                <a:cs typeface="Times New Roman"/>
               </a:rPr>
               <a:t>Reward (how it is scored)</a:t>
             </a:r>
@@ -7502,9 +7688,11 @@
                 <a:solidFill>
                   <a:srgbClr val="000000"/>
                 </a:solidFill>
-                <a:latin typeface="Arial"/>
-              </a:rPr>
-              <a:t>Reward = 20 × (total throughput / 10) + 20 × Jain fairness − delay penalty − loss penalty</a:t>
+                <a:latin typeface="Times New Roman"/>
+                <a:ea typeface="Times New Roman"/>
+                <a:cs typeface="Times New Roman"/>
+              </a:rPr>
+              <a:t>Reward = 60 × min(total throughput / 10, 1) + 20 × Jain fairness − 0.3 × delay(ms) − 20 × loss − 0.0005 × window(bytes)</a:t>
             </a:r>
           </a:p>
           <a:p>
@@ -7518,9 +7706,11 @@
                 <a:solidFill>
                   <a:srgbClr val="000000"/>
                 </a:solidFill>
-                <a:latin typeface="Arial"/>
-              </a:rPr>
-              <a:t>Jain's Fairness Index is 1.0 when bandwidth is shared equally. If one agent starves the other, fairness and delay penalties cancel its throughput gain.</a:t>
+                <a:latin typeface="Times New Roman"/>
+                <a:ea typeface="Times New Roman"/>
+                <a:cs typeface="Times New Roman"/>
+              </a:rPr>
+              <a:t>Jain's Fairness Index is 1.0 when bandwidth is shared equally. The window charge stops both agents from filling the router queue without limit, and the delay penalty keeps the queue short.</a:t>
             </a:r>
           </a:p>
         </p:txBody>
@@ -7611,8 +7801,9 @@
             <a:pPr algn="ctr"/>
             <a:r>
               <a:rPr lang="en-GB" sz="4000" dirty="0">
-                <a:latin typeface="Corbel" panose="020B0503020204020204" pitchFamily="34" charset="0"/>
-                <a:cs typeface="Arial" panose="020B0604020202020204" pitchFamily="34" charset="0"/>
+                <a:latin typeface="Times New Roman" panose="020B0503020204020204" pitchFamily="34" charset="0"/>
+                <a:cs typeface="Times New Roman" panose="020B0604020202020204" pitchFamily="34" charset="0"/>
+                <a:ea typeface="Times New Roman"/>
               </a:rPr>
               <a:t>DESIGN AND IMPLEMENTATION</a:t>
             </a:r>
@@ -7677,7 +7868,11 @@
           <a:lstStyle/>
           <a:p>
             <a:r>
-              <a:rPr lang="en-US" dirty="0"/>
+              <a:rPr lang="en-US" dirty="0">
+                <a:latin typeface="Times New Roman"/>
+                <a:ea typeface="Times New Roman"/>
+                <a:cs typeface="Times New Roman"/>
+              </a:rPr>
               <a:t>Department of Software Engineering -  Project  ©2025</a:t>
             </a:r>
             <a:endParaRPr lang="en-GB" dirty="0"/>
@@ -7781,7 +7976,9 @@
                 <a:solidFill>
                   <a:srgbClr val="404040"/>
                 </a:solidFill>
-                <a:latin typeface="Arial"/>
+                <a:latin typeface="Times New Roman"/>
+                <a:ea typeface="Times New Roman"/>
+                <a:cs typeface="Times New Roman"/>
               </a:rPr>
               <a:t>Figure 3.1: Multi-agent simulation testbed.</a:t>
             </a:r>
@@ -7821,7 +8018,9 @@
                 <a:solidFill>
                   <a:srgbClr val="000000"/>
                 </a:solidFill>
-                <a:latin typeface="Arial"/>
+                <a:latin typeface="Times New Roman"/>
+                <a:ea typeface="Times New Roman"/>
+                <a:cs typeface="Times New Roman"/>
               </a:rPr>
               <a:t>Network: </a:t>
             </a:r>
@@ -7830,7 +8029,9 @@
                 <a:solidFill>
                   <a:srgbClr val="000000"/>
                 </a:solidFill>
-                <a:latin typeface="Arial"/>
+                <a:latin typeface="Times New Roman"/>
+                <a:ea typeface="Times New Roman"/>
+                <a:cs typeface="Times New Roman"/>
               </a:rPr>
               <a:t>two senders share one bottleneck link of 10 Mbps with 20 ms one-way delay. The router uses a DropTail queue (drops new packets when full) holding 100 packets.</a:t>
             </a:r>
@@ -7847,7 +8048,9 @@
                 <a:solidFill>
                   <a:srgbClr val="000000"/>
                 </a:solidFill>
-                <a:latin typeface="Arial"/>
+                <a:latin typeface="Times New Roman"/>
+                <a:ea typeface="Times New Roman"/>
+                <a:cs typeface="Times New Roman"/>
               </a:rPr>
               <a:t>Bridge: </a:t>
             </a:r>
@@ -7856,7 +8059,9 @@
                 <a:solidFill>
                   <a:srgbClr val="000000"/>
                 </a:solidFill>
-                <a:latin typeface="Arial"/>
+                <a:latin typeface="Times New Roman"/>
+                <a:ea typeface="Times New Roman"/>
+                <a:cs typeface="Times New Roman"/>
               </a:rPr>
               <a:t>ns3-gym exposes ns-3 to Python through Gymnasium. ZeroMQ carries messages and Protocol Buffers (a binary data format) packs them.</a:t>
             </a:r>
@@ -7873,7 +8078,9 @@
                 <a:solidFill>
                   <a:srgbClr val="000000"/>
                 </a:solidFill>
-                <a:latin typeface="Arial"/>
+                <a:latin typeface="Times New Roman"/>
+                <a:ea typeface="Times New Roman"/>
+                <a:cs typeface="Times New Roman"/>
               </a:rPr>
               <a:t>Training: Stable-Baselines3, built on PyTorch, runs PPO with a shared policy. The delivered policy was warm-started by behaviour cloning from a reference controller and then refined with PPO. The agent chooses a new action every 100 ms.</a:t>
             </a:r>
@@ -7882,7 +8089,9 @@
                 <a:solidFill>
                   <a:srgbClr val="000000"/>
                 </a:solidFill>
-                <a:latin typeface="Arial"/>
+                <a:latin typeface="Times New Roman"/>
+                <a:ea typeface="Times New Roman"/>
+                <a:cs typeface="Times New Roman"/>
               </a:rPr>
               <a:t/>
             </a:r>
@@ -7921,7 +8130,9 @@
                 <a:solidFill>
                   <a:srgbClr val="000000"/>
                 </a:solidFill>
-                <a:latin typeface="Arial"/>
+                <a:latin typeface="Times New Roman"/>
+                <a:ea typeface="Times New Roman"/>
+                <a:cs typeface="Times New Roman"/>
               </a:rPr>
               <a:t>Problems found and fixed during implementation</a:t>
             </a:r>
@@ -7978,7 +8189,9 @@
                 <a:solidFill>
                   <a:srgbClr val="000000"/>
                 </a:solidFill>
-                <a:latin typeface="Arial"/>
+                <a:latin typeface="Times New Roman"/>
+                <a:ea typeface="Times New Roman"/>
+                <a:cs typeface="Times New Roman"/>
               </a:rPr>
               <a:t>Throughput read as zero</a:t>
             </a:r>
@@ -7994,7 +8207,9 @@
                 <a:solidFill>
                   <a:srgbClr val="000000"/>
                 </a:solidFill>
-                <a:latin typeface="Arial"/>
+                <a:latin typeface="Times New Roman"/>
+                <a:ea typeface="Times New Roman"/>
+                <a:cs typeface="Times New Roman"/>
               </a:rPr>
               <a:t>Throughput was summed from bytes in flight. It now reads delivered bytes from the receiver.</a:t>
             </a:r>
@@ -8051,7 +8266,9 @@
                 <a:solidFill>
                   <a:srgbClr val="000000"/>
                 </a:solidFill>
-                <a:latin typeface="Arial"/>
+                <a:latin typeface="Times New Roman"/>
+                <a:ea typeface="Times New Roman"/>
+                <a:cs typeface="Times New Roman"/>
               </a:rPr>
               <a:t>Window set to 1100 bytes</a:t>
             </a:r>
@@ -8067,7 +8284,9 @@
                 <a:solidFill>
                   <a:srgbClr val="000000"/>
                 </a:solidFill>
-                <a:latin typeface="Arial"/>
+                <a:latin typeface="Times New Roman"/>
+                <a:ea typeface="Times New Roman"/>
+                <a:cs typeface="Times New Roman"/>
               </a:rPr>
               <a:t>Actions set an absolute value. They now scale the current window by the chosen multiplier.</a:t>
             </a:r>
@@ -8124,7 +8343,9 @@
                 <a:solidFill>
                   <a:srgbClr val="000000"/>
                 </a:solidFill>
-                <a:latin typeface="Arial"/>
+                <a:latin typeface="Times New Roman"/>
+                <a:ea typeface="Times New Roman"/>
+                <a:cs typeface="Times New Roman"/>
               </a:rPr>
               <a:t>Training crashed with NaN</a:t>
             </a:r>
@@ -8140,7 +8361,9 @@
                 <a:solidFill>
                   <a:srgbClr val="000000"/>
                 </a:solidFill>
-                <a:latin typeface="Arial"/>
+                <a:latin typeface="Times New Roman"/>
+                <a:ea typeface="Times New Roman"/>
+                <a:cs typeface="Times New Roman"/>
               </a:rPr>
               <a:t>Unscaled inputs broke the training. A Python wrapper now normalizes them.</a:t>
             </a:r>
@@ -8257,8 +8480,9 @@
             <a:pPr algn="ctr"/>
             <a:r>
               <a:rPr lang="en-GB" sz="4000" dirty="0">
-                <a:latin typeface="Corbel" panose="020B0503020204020204" pitchFamily="34" charset="0"/>
-                <a:cs typeface="Arial" panose="020B0604020202020204" pitchFamily="34" charset="0"/>
+                <a:latin typeface="Times New Roman" panose="020B0503020204020204" pitchFamily="34" charset="0"/>
+                <a:cs typeface="Times New Roman" panose="020B0604020202020204" pitchFamily="34" charset="0"/>
+                <a:ea typeface="Times New Roman"/>
               </a:rPr>
               <a:t>RESULTS/FINDINGS</a:t>
             </a:r>
@@ -8323,7 +8547,11 @@
           <a:lstStyle/>
           <a:p>
             <a:r>
-              <a:rPr lang="en-US" dirty="0"/>
+              <a:rPr lang="en-US" dirty="0">
+                <a:latin typeface="Times New Roman"/>
+                <a:ea typeface="Times New Roman"/>
+                <a:cs typeface="Times New Roman"/>
+              </a:rPr>
               <a:t>Department of Software Engineering -  Project ©2025</a:t>
             </a:r>
             <a:endParaRPr lang="en-GB" dirty="0"/>
@@ -8427,7 +8655,9 @@
                 <a:solidFill>
                   <a:srgbClr val="000000"/>
                 </a:solidFill>
-                <a:latin typeface="Arial"/>
+                <a:latin typeface="Times New Roman"/>
+                <a:ea typeface="Times New Roman"/>
+                <a:cs typeface="Times New Roman"/>
               </a:rPr>
               <a:t>Two-agent evaluation, 60-second run (Table 4.1)</a:t>
             </a:r>
@@ -8468,7 +8698,9 @@
                           <a:solidFill>
                             <a:srgbClr val="000000"/>
                           </a:solidFill>
-                          <a:latin typeface="Arial"/>
+                          <a:latin typeface="Times New Roman"/>
+                          <a:ea typeface="Times New Roman"/>
+                          <a:cs typeface="Times New Roman"/>
                         </a:rPr>
                         <a:t>Metric</a:t>
                       </a:r>
@@ -8496,7 +8728,9 @@
                           <a:solidFill>
                             <a:srgbClr val="000000"/>
                           </a:solidFill>
-                          <a:latin typeface="Arial"/>
+                          <a:latin typeface="Times New Roman"/>
+                          <a:ea typeface="Times New Roman"/>
+                          <a:cs typeface="Times New Roman"/>
                         </a:rPr>
                         <a:t>Agent 1</a:t>
                       </a:r>
@@ -8524,7 +8758,9 @@
                           <a:solidFill>
                             <a:srgbClr val="000000"/>
                           </a:solidFill>
-                          <a:latin typeface="Arial"/>
+                          <a:latin typeface="Times New Roman"/>
+                          <a:ea typeface="Times New Roman"/>
+                          <a:cs typeface="Times New Roman"/>
                         </a:rPr>
                         <a:t>Agent 2</a:t>
                       </a:r>
@@ -8552,7 +8788,9 @@
                           <a:solidFill>
                             <a:srgbClr val="000000"/>
                           </a:solidFill>
-                          <a:latin typeface="Arial"/>
+                          <a:latin typeface="Times New Roman"/>
+                          <a:ea typeface="Times New Roman"/>
+                          <a:cs typeface="Times New Roman"/>
                         </a:rPr>
                         <a:t>Total / Average</a:t>
                       </a:r>
@@ -8582,7 +8820,9 @@
                           <a:solidFill>
                             <a:srgbClr val="000000"/>
                           </a:solidFill>
-                          <a:latin typeface="Arial"/>
+                          <a:latin typeface="Times New Roman"/>
+                          <a:ea typeface="Times New Roman"/>
+                          <a:cs typeface="Times New Roman"/>
                         </a:rPr>
                         <a:t>Throughput</a:t>
                       </a:r>
@@ -8610,7 +8850,9 @@
                           <a:solidFill>
                             <a:srgbClr val="000000"/>
                           </a:solidFill>
-                          <a:latin typeface="Arial"/>
+                          <a:latin typeface="Times New Roman"/>
+                          <a:ea typeface="Times New Roman"/>
+                          <a:cs typeface="Times New Roman"/>
                         </a:rPr>
                         <a:t>4348.2 kbps</a:t>
                       </a:r>
@@ -8638,7 +8880,9 @@
                           <a:solidFill>
                             <a:srgbClr val="000000"/>
                           </a:solidFill>
-                          <a:latin typeface="Arial"/>
+                          <a:latin typeface="Times New Roman"/>
+                          <a:ea typeface="Times New Roman"/>
+                          <a:cs typeface="Times New Roman"/>
                         </a:rPr>
                         <a:t>4348.2 kbps</a:t>
                       </a:r>
@@ -8666,7 +8910,9 @@
                           <a:solidFill>
                             <a:srgbClr val="000000"/>
                           </a:solidFill>
-                          <a:latin typeface="Arial"/>
+                          <a:latin typeface="Times New Roman"/>
+                          <a:ea typeface="Times New Roman"/>
+                          <a:cs typeface="Times New Roman"/>
                         </a:rPr>
                         <a:t>8696.3 kbps</a:t>
                       </a:r>
@@ -8696,7 +8942,9 @@
                           <a:solidFill>
                             <a:srgbClr val="000000"/>
                           </a:solidFill>
-                          <a:latin typeface="Arial"/>
+                          <a:latin typeface="Times New Roman"/>
+                          <a:ea typeface="Times New Roman"/>
+                          <a:cs typeface="Times New Roman"/>
                         </a:rPr>
                         <a:t>Delay</a:t>
                       </a:r>
@@ -8724,7 +8972,9 @@
                           <a:solidFill>
                             <a:srgbClr val="000000"/>
                           </a:solidFill>
-                          <a:latin typeface="Arial"/>
+                          <a:latin typeface="Times New Roman"/>
+                          <a:ea typeface="Times New Roman"/>
+                          <a:cs typeface="Times New Roman"/>
                         </a:rPr>
                         <a:t>22.81 ms</a:t>
                       </a:r>
@@ -8752,7 +9002,9 @@
                           <a:solidFill>
                             <a:srgbClr val="000000"/>
                           </a:solidFill>
-                          <a:latin typeface="Arial"/>
+                          <a:latin typeface="Times New Roman"/>
+                          <a:ea typeface="Times New Roman"/>
+                          <a:cs typeface="Times New Roman"/>
                         </a:rPr>
                         <a:t>22.80 ms</a:t>
                       </a:r>
@@ -8780,7 +9032,9 @@
                           <a:solidFill>
                             <a:srgbClr val="000000"/>
                           </a:solidFill>
-                          <a:latin typeface="Arial"/>
+                          <a:latin typeface="Times New Roman"/>
+                          <a:ea typeface="Times New Roman"/>
+                          <a:cs typeface="Times New Roman"/>
                         </a:rPr>
                         <a:t>22.80 ms</a:t>
                       </a:r>
@@ -8810,7 +9064,9 @@
                           <a:solidFill>
                             <a:srgbClr val="000000"/>
                           </a:solidFill>
-                          <a:latin typeface="Arial"/>
+                          <a:latin typeface="Times New Roman"/>
+                          <a:ea typeface="Times New Roman"/>
+                          <a:cs typeface="Times New Roman"/>
                         </a:rPr>
                         <a:t>Loss ratio</a:t>
                       </a:r>
@@ -8838,7 +9094,9 @@
                           <a:solidFill>
                             <a:srgbClr val="000000"/>
                           </a:solidFill>
-                          <a:latin typeface="Arial"/>
+                          <a:latin typeface="Times New Roman"/>
+                          <a:ea typeface="Times New Roman"/>
+                          <a:cs typeface="Times New Roman"/>
                         </a:rPr>
                         <a:t>0.00%</a:t>
                       </a:r>
@@ -8866,7 +9124,9 @@
                           <a:solidFill>
                             <a:srgbClr val="000000"/>
                           </a:solidFill>
-                          <a:latin typeface="Arial"/>
+                          <a:latin typeface="Times New Roman"/>
+                          <a:ea typeface="Times New Roman"/>
+                          <a:cs typeface="Times New Roman"/>
                         </a:rPr>
                         <a:t>0.00%</a:t>
                       </a:r>
@@ -8894,7 +9154,9 @@
                           <a:solidFill>
                             <a:srgbClr val="000000"/>
                           </a:solidFill>
-                          <a:latin typeface="Arial"/>
+                          <a:latin typeface="Times New Roman"/>
+                          <a:ea typeface="Times New Roman"/>
+                          <a:cs typeface="Times New Roman"/>
                         </a:rPr>
                         <a:t>0.000%</a:t>
                       </a:r>
@@ -8924,7 +9186,9 @@
                           <a:solidFill>
                             <a:srgbClr val="000000"/>
                           </a:solidFill>
-                          <a:latin typeface="Arial"/>
+                          <a:latin typeface="Times New Roman"/>
+                          <a:ea typeface="Times New Roman"/>
+                          <a:cs typeface="Times New Roman"/>
                         </a:rPr>
                         <a:t>Jain's Fairness</a:t>
                       </a:r>
@@ -8952,7 +9216,9 @@
                           <a:solidFill>
                             <a:srgbClr val="000000"/>
                           </a:solidFill>
-                          <a:latin typeface="Arial"/>
+                          <a:latin typeface="Times New Roman"/>
+                          <a:ea typeface="Times New Roman"/>
+                          <a:cs typeface="Times New Roman"/>
                         </a:rPr>
                         <a:t>-</a:t>
                       </a:r>
@@ -8980,7 +9246,9 @@
                           <a:solidFill>
                             <a:srgbClr val="000000"/>
                           </a:solidFill>
-                          <a:latin typeface="Arial"/>
+                          <a:latin typeface="Times New Roman"/>
+                          <a:ea typeface="Times New Roman"/>
+                          <a:cs typeface="Times New Roman"/>
                         </a:rPr>
                         <a:t>-</a:t>
                       </a:r>
@@ -9008,7 +9276,9 @@
                           <a:solidFill>
                             <a:srgbClr val="000000"/>
                           </a:solidFill>
-                          <a:latin typeface="Arial"/>
+                          <a:latin typeface="Times New Roman"/>
+                          <a:ea typeface="Times New Roman"/>
+                          <a:cs typeface="Times New Roman"/>
                         </a:rPr>
                         <a:t>1.0000</a:t>
                       </a:r>
@@ -9076,7 +9346,9 @@
                 <a:solidFill>
                   <a:srgbClr val="000000"/>
                 </a:solidFill>
-                <a:latin typeface="Arial"/>
+                <a:latin typeface="Times New Roman"/>
+                <a:ea typeface="Times New Roman"/>
+                <a:cs typeface="Times New Roman"/>
               </a:rPr>
               <a:t>86.96%</a:t>
             </a:r>
@@ -9088,7 +9360,9 @@
                 <a:solidFill>
                   <a:srgbClr val="000000"/>
                 </a:solidFill>
-                <a:latin typeface="Arial"/>
+                <a:latin typeface="Times New Roman"/>
+                <a:ea typeface="Times New Roman"/>
+                <a:cs typeface="Times New Roman"/>
               </a:rPr>
               <a:t>of the 10 Mbps link used</a:t>
             </a:r>
@@ -9141,7 +9415,9 @@
                 <a:solidFill>
                   <a:srgbClr val="000000"/>
                 </a:solidFill>
-                <a:latin typeface="Arial"/>
+                <a:latin typeface="Times New Roman"/>
+                <a:ea typeface="Times New Roman"/>
+                <a:cs typeface="Times New Roman"/>
               </a:rPr>
               <a:t>1.0000</a:t>
             </a:r>
@@ -9153,7 +9429,9 @@
                 <a:solidFill>
                   <a:srgbClr val="000000"/>
                 </a:solidFill>
-                <a:latin typeface="Arial"/>
+                <a:latin typeface="Times New Roman"/>
+                <a:ea typeface="Times New Roman"/>
+                <a:cs typeface="Times New Roman"/>
               </a:rPr>
               <a:t>Jain's Fairness Index (1.0 is equal)</a:t>
             </a:r>
@@ -9210,7 +9488,9 @@
                 <a:solidFill>
                   <a:srgbClr val="000000"/>
                 </a:solidFill>
-                <a:latin typeface="Arial"/>
+                <a:latin typeface="Times New Roman"/>
+                <a:ea typeface="Times New Roman"/>
+                <a:cs typeface="Times New Roman"/>
               </a:rPr>
               <a:t>Training</a:t>
             </a:r>
@@ -9226,7 +9506,9 @@
                 <a:solidFill>
                   <a:srgbClr val="000000"/>
                 </a:solidFill>
-                <a:latin typeface="Arial"/>
+                <a:latin typeface="Times New Roman"/>
+                <a:ea typeface="Times New Roman"/>
+                <a:cs typeface="Times New Roman"/>
               </a:rPr>
               <a:t>The shared policy was warm-started by behaviour cloning from a reference controller and then refined with PPO. It holds the window near the bandwidth-delay product of the bottleneck.</a:t>
             </a:r>
@@ -9343,8 +9625,9 @@
             <a:pPr algn="ctr"/>
             <a:r>
               <a:rPr lang="en-GB" sz="4000" dirty="0">
-                <a:latin typeface="Corbel" panose="020B0503020204020204" pitchFamily="34" charset="0"/>
-                <a:cs typeface="Arial" panose="020B0604020202020204" pitchFamily="34" charset="0"/>
+                <a:latin typeface="Times New Roman" panose="020B0503020204020204" pitchFamily="34" charset="0"/>
+                <a:cs typeface="Times New Roman" panose="020B0604020202020204" pitchFamily="34" charset="0"/>
+                <a:ea typeface="Times New Roman"/>
               </a:rPr>
               <a:t>RESULTS/FINDINGS (CONTINUED)</a:t>
             </a:r>
@@ -9409,7 +9692,11 @@
           <a:lstStyle/>
           <a:p>
             <a:r>
-              <a:rPr lang="en-US" dirty="0"/>
+              <a:rPr lang="en-US" dirty="0">
+                <a:latin typeface="Times New Roman"/>
+                <a:ea typeface="Times New Roman"/>
+                <a:cs typeface="Times New Roman"/>
+              </a:rPr>
               <a:t>Department of Software Engineering -  Project ©2025</a:t>
             </a:r>
             <a:endParaRPr lang="en-GB" dirty="0"/>
@@ -9513,7 +9800,9 @@
                 <a:solidFill>
                   <a:srgbClr val="000000"/>
                 </a:solidFill>
-                <a:latin typeface="Arial"/>
+                <a:latin typeface="Times New Roman"/>
+                <a:ea typeface="Times New Roman"/>
+                <a:cs typeface="Times New Roman"/>
               </a:rPr>
               <a:t>An earlier evaluation produced numbers identical to two standard TCP CUBIC flows. The fault was found and corrected, and the policy now controls the congestion window.</a:t>
             </a:r>
@@ -9570,7 +9859,9 @@
                 <a:solidFill>
                   <a:srgbClr val="000000"/>
                 </a:solidFill>
-                <a:latin typeface="Arial"/>
+                <a:latin typeface="Times New Roman"/>
+                <a:ea typeface="Times New Roman"/>
+                <a:cs typeface="Times New Roman"/>
               </a:rPr>
               <a:t>1. Configuration order</a:t>
             </a:r>
@@ -9586,7 +9877,9 @@
                 <a:solidFill>
                   <a:srgbClr val="000000"/>
                 </a:solidFill>
-                <a:latin typeface="Arial"/>
+                <a:latin typeface="Times New Roman"/>
+                <a:ea typeface="Times New Roman"/>
+                <a:cs typeface="Times New Roman"/>
               </a:rPr>
               <a:t>A custom no-op class disables ns-3 congestion control. It was configured before the TCP protocol object existed, so the setting matched nothing.</a:t>
             </a:r>
@@ -9643,7 +9936,9 @@
                 <a:solidFill>
                   <a:srgbClr val="000000"/>
                 </a:solidFill>
-                <a:latin typeface="Arial"/>
+                <a:latin typeface="Times New Roman"/>
+                <a:ea typeface="Times New Roman"/>
+                <a:cs typeface="Times New Roman"/>
               </a:rPr>
               <a:t>2. Silent default</a:t>
             </a:r>
@@ -9659,7 +9954,9 @@
                 <a:solidFill>
                   <a:srgbClr val="000000"/>
                 </a:solidFill>
-                <a:latin typeface="Arial"/>
+                <a:latin typeface="Times New Roman"/>
+                <a:ea typeface="Times New Roman"/>
+                <a:cs typeface="Times New Roman"/>
               </a:rPr>
               <a:t>The configuration function does not report a miss. Every socket used the default, TCP CUBIC, which changed the window on every acknowledgment.</a:t>
             </a:r>
@@ -9716,7 +10013,9 @@
                 <a:solidFill>
                   <a:srgbClr val="000000"/>
                 </a:solidFill>
-                <a:latin typeface="Arial"/>
+                <a:latin typeface="Times New Roman"/>
+                <a:ea typeface="Times New Roman"/>
+                <a:cs typeface="Times New Roman"/>
               </a:rPr>
               <a:t>3. Corrected and verified</a:t>
             </a:r>
@@ -9732,7 +10031,9 @@
                 <a:solidFill>
                   <a:srgbClr val="000000"/>
                 </a:solidFill>
-                <a:latin typeface="Arial"/>
+                <a:latin typeface="Times New Roman"/>
+                <a:ea typeface="Times New Roman"/>
+                <a:cs typeface="Times New Roman"/>
               </a:rPr>
               <a:t>The setting now runs after the internet stack installs and aborts on a miss. The program prints the live algorithm name, NoOpTcpCongestion.</a:t>
             </a:r>
@@ -9789,7 +10090,9 @@
                 <a:solidFill>
                   <a:srgbClr val="000000"/>
                 </a:solidFill>
-                <a:latin typeface="Arial"/>
+                <a:latin typeface="Times New Roman"/>
+                <a:ea typeface="Times New Roman"/>
+                <a:cs typeface="Times New Roman"/>
               </a:rPr>
               <a:t>What holds now</a:t>
             </a:r>
@@ -9805,7 +10108,9 @@
                 <a:solidFill>
                   <a:srgbClr val="000000"/>
                 </a:solidFill>
-                <a:latin typeface="Arial"/>
+                <a:latin typeface="Times New Roman"/>
+                <a:ea typeface="Times New Roman"/>
+                <a:cs typeface="Times New Roman"/>
               </a:rPr>
               <a:t>The RL actions own the window. A constant hold action keeps cwnd at exactly 5,360 bytes, which CUBIC cannot do.</a:t>
             </a:r>
@@ -9821,7 +10126,9 @@
                 <a:solidFill>
                   <a:srgbClr val="000000"/>
                 </a:solidFill>
-                <a:latin typeface="Arial"/>
+                <a:latin typeface="Times New Roman"/>
+                <a:ea typeface="Times New Roman"/>
+                <a:cs typeface="Times New Roman"/>
               </a:rPr>
               <a:t>The corrected policy keeps 86.96 percent of the link busy with 22.80 ms delay, no measured loss and a Jain fairness index of 1.0000.</a:t>
             </a:r>

</xml_diff>